<commit_message>
Presentación final del proyecto y Lean Canvas con cifras del equipo (equilibrio en 75 trabajos)
Co-Authored-By: Claude Opus 5.5 <noreply@anthropic.com>
</commit_message>
<xml_diff>
--- a/docs/Lean_Canvas_Handyman.pptx
+++ b/docs/Lean_Canvas_Handyman.pptx
@@ -2090,7 +2090,7 @@
                 <a:ea typeface="Calibri" pitchFamily="34" charset="-122"/>
                 <a:cs typeface="Calibri" pitchFamily="34" charset="-120"/>
               </a:rPr>
-              <a:t>CAC &lt; Q 65 (se recupera en 2 órdenes)</a:t>
+              <a:t>CAC &lt; Q 50 (se recupera con la 1.ª orden)</a:t>
             </a:r>
             <a:endParaRPr lang="en-US" sz="850" dirty="0"/>
           </a:p>
@@ -3769,7 +3769,7 @@
                 <a:ea typeface="Calibri" pitchFamily="34" charset="-122"/>
                 <a:cs typeface="Calibri" pitchFamily="34" charset="-120"/>
               </a:rPr>
-              <a:t>Comisión del 12 % al profesional por trabajo pagado en la plataforma</a:t>
+              <a:t>Comisión del 10 % al profesional por trabajo pagado en la plataforma</a:t>
             </a:r>
             <a:endParaRPr lang="en-US" sz="850" dirty="0"/>
           </a:p>
@@ -5686,7 +5686,7 @@
                           <a:ea typeface="Calibri" pitchFamily="34" charset="-122"/>
                           <a:cs typeface="Calibri" pitchFamily="34" charset="-120"/>
                         </a:rPr>
-                        <a:t>Creemos que el cliente acepta pagar Q 15 por la garantía y el profesional ceder 12 %.</a:t>
+                        <a:t>Creemos que el cliente acepta pagar Q 15 por la garantía y el profesional ceder 10 %.</a:t>
                       </a:r>
                       <a:endParaRPr lang="en-US" sz="950" dirty="0">
                         <a:latin typeface="Calibri" charset="0"/>
@@ -6096,7 +6096,7 @@
                           <a:ea typeface="Calibri" pitchFamily="34" charset="-122"/>
                           <a:cs typeface="Calibri" pitchFamily="34" charset="-120"/>
                         </a:rPr>
-                        <a:t>Canal ganador con CAC &lt; Q 65</a:t>
+                        <a:t>Canal ganador con CAC &lt; Q 50</a:t>
                       </a:r>
                       <a:endParaRPr lang="en-US" sz="950" dirty="0">
                         <a:latin typeface="Calibri" charset="0"/>
@@ -6796,7 +6796,7 @@
                           <a:ea typeface="Poppins" pitchFamily="34" charset="-122"/>
                           <a:cs typeface="Poppins" pitchFamily="34" charset="-120"/>
                         </a:rPr>
-                        <a:t>Q 450.00</a:t>
+                        <a:t>Q 1000.00</a:t>
                       </a:r>
                       <a:endParaRPr lang="en-US" sz="1300" dirty="0">
                         <a:latin typeface="Poppins" charset="0"/>
@@ -6863,7 +6863,7 @@
                           <a:ea typeface="Calibri" pitchFamily="34" charset="-122"/>
                           <a:cs typeface="Calibri" pitchFamily="34" charset="-120"/>
                         </a:rPr>
-                        <a:t>Comisión Handyman (12 %)</a:t>
+                        <a:t>Comisión Handyman (10 %)</a:t>
                       </a:r>
                       <a:endParaRPr lang="en-US" sz="1300" dirty="0">
                         <a:latin typeface="Calibri" charset="0"/>
@@ -6928,7 +6928,7 @@
                           <a:ea typeface="Poppins" pitchFamily="34" charset="-122"/>
                           <a:cs typeface="Poppins" pitchFamily="34" charset="-120"/>
                         </a:rPr>
-                        <a:t>Q 54.00</a:t>
+                        <a:t>Q 100.00</a:t>
                       </a:r>
                       <a:endParaRPr lang="en-US" sz="1300" dirty="0">
                         <a:latin typeface="Poppins" charset="0"/>
@@ -7127,7 +7127,7 @@
                           <a:ea typeface="Calibri" pitchFamily="34" charset="-122"/>
                           <a:cs typeface="Calibri" pitchFamily="34" charset="-120"/>
                         </a:rPr>
-                        <a:t>Pasarela de pago (≈ 4 % de Q 465)</a:t>
+                        <a:t>Pasarela de pago (≈ 4 % de Q 1,015)</a:t>
                       </a:r>
                       <a:endParaRPr lang="en-US" sz="1300" dirty="0">
                         <a:latin typeface="Calibri" charset="0"/>
@@ -7192,7 +7192,7 @@
                           <a:ea typeface="Poppins" pitchFamily="34" charset="-122"/>
                           <a:cs typeface="Poppins" pitchFamily="34" charset="-120"/>
                         </a:rPr>
-                        <a:t>– Q 18.60</a:t>
+                        <a:t>– Q 40.60</a:t>
                       </a:r>
                       <a:endParaRPr lang="en-US" sz="1300" dirty="0">
                         <a:latin typeface="Poppins" charset="0"/>
@@ -7324,7 +7324,7 @@
                           <a:ea typeface="Poppins" pitchFamily="34" charset="-122"/>
                           <a:cs typeface="Poppins" pitchFamily="34" charset="-120"/>
                         </a:rPr>
-                        <a:t>– Q 9.00</a:t>
+                        <a:t>– Q 20.00</a:t>
                       </a:r>
                       <a:endParaRPr lang="en-US" sz="1300" dirty="0">
                         <a:latin typeface="Poppins" charset="0"/>
@@ -7459,7 +7459,7 @@
                           <a:ea typeface="Poppins" pitchFamily="34" charset="-122"/>
                           <a:cs typeface="Poppins" pitchFamily="34" charset="-120"/>
                         </a:rPr>
-                        <a:t>Q 41.40</a:t>
+                        <a:t>Q 54.40</a:t>
                       </a:r>
                       <a:endParaRPr lang="en-US" sz="1600" dirty="0">
                         <a:latin typeface="Poppins" charset="0"/>
@@ -7575,7 +7575,7 @@
                 <a:ea typeface="Poppins" pitchFamily="34" charset="-122"/>
                 <a:cs typeface="Poppins" pitchFamily="34" charset="-120"/>
               </a:rPr>
-              <a:t>Q 41</a:t>
+              <a:t>Q 54</a:t>
             </a:r>
             <a:endParaRPr lang="en-US" sz="2400" dirty="0"/>
           </a:p>
@@ -7680,7 +7680,7 @@
                 <a:ea typeface="Poppins" pitchFamily="34" charset="-122"/>
                 <a:cs typeface="Poppins" pitchFamily="34" charset="-120"/>
               </a:rPr>
-              <a:t>&lt; Q 65</a:t>
+              <a:t>&lt; Q 50</a:t>
             </a:r>
             <a:endParaRPr lang="en-US" sz="2400" dirty="0"/>
           </a:p>
@@ -7785,7 +7785,7 @@
                 <a:ea typeface="Poppins" pitchFamily="34" charset="-122"/>
                 <a:cs typeface="Poppins" pitchFamily="34" charset="-120"/>
               </a:rPr>
-              <a:t>≥ 2</a:t>
+              <a:t>1 orden</a:t>
             </a:r>
             <a:endParaRPr lang="en-US" sz="2400" dirty="0"/>
           </a:p>
@@ -7824,7 +7824,7 @@
                 <a:ea typeface="Calibri" pitchFamily="34" charset="-122"/>
                 <a:cs typeface="Calibri" pitchFamily="34" charset="-120"/>
               </a:rPr>
-              <a:t>órdenes por cliente al año para recuperar el CAC con ganancia</a:t>
+              <a:t>recupera el CAC: el 76.2 % contrata solo 1 o 2 trabajos al año</a:t>
             </a:r>
             <a:endParaRPr lang="en-US" sz="1200" dirty="0"/>
           </a:p>
@@ -7890,7 +7890,7 @@
                 <a:ea typeface="Poppins" pitchFamily="34" charset="-122"/>
                 <a:cs typeface="Poppins" pitchFamily="34" charset="-120"/>
               </a:rPr>
-              <a:t>≈ 290</a:t>
+              <a:t>≈ 75</a:t>
             </a:r>
             <a:endParaRPr lang="en-US" sz="2400" dirty="0"/>
           </a:p>
@@ -7929,7 +7929,7 @@
                 <a:ea typeface="Calibri" pitchFamily="34" charset="-122"/>
                 <a:cs typeface="Calibri" pitchFamily="34" charset="-120"/>
               </a:rPr>
-              <a:t>órdenes al mes para cubrir Q 12,000 de costos fijos del piloto</a:t>
+              <a:t>trabajos al mes para cubrir Q 4,080 de costos fijos (punto de equilibrio)</a:t>
             </a:r>
             <a:endParaRPr lang="en-US" sz="1200" dirty="0"/>
           </a:p>
@@ -7968,7 +7968,7 @@
                 <a:ea typeface="Calibri" pitchFamily="34" charset="-122"/>
                 <a:cs typeface="Calibri" pitchFamily="34" charset="-120"/>
               </a:rPr>
-              <a:t>Supuestos del piloto (a validar): trabajo promedio Q 450 según precios típicos de los oficios en la ciudad; costos fijos de Q 12,000 al mes (1 agente de soporte, plataforma y marketing base). Las emergencias suman Q 37.50 por visita.</a:t>
+              <a:t>Supuestos del piloto (a validar): trabajo promedio de Q 1,000, porque el 47.6 % de la encuesta pagó entre Q 500 y Q 1,500 por su último trabajo; comisión de 10 %, porque el 61.9 % no pagaría más de 10 % extra; costos fijos de Q 4,080 al mes, porque el equipo y la oficina los aporta Artefacto Creativo. Las emergencias suman Q 37.50 por visita.</a:t>
             </a:r>
             <a:endParaRPr lang="en-US" sz="1050" dirty="0"/>
           </a:p>

</xml_diff>

<commit_message>
Reto: Reinventar lo cotidiano; tamaño de mercado y costos con salario mínimo 2026 y pasarela local
Co-Authored-By: Claude Opus 5.5 <noreply@anthropic.com>
</commit_message>
<xml_diff>
--- a/docs/Lean_Canvas_Handyman.pptx
+++ b/docs/Lean_Canvas_Handyman.pptx
@@ -3496,7 +3496,7 @@
                 <a:ea typeface="Calibri" pitchFamily="34" charset="-122"/>
                 <a:cs typeface="Calibri" pitchFamily="34" charset="-120"/>
               </a:rPr>
-              <a:t>Pasarela de pago (≈ 4 % por transacción)</a:t>
+              <a:t>Pasarela de pago (4.5 % con tarjeta; transferencia sin costo)</a:t>
             </a:r>
             <a:endParaRPr lang="en-US" sz="850" dirty="0"/>
           </a:p>
@@ -6796,7 +6796,7 @@
                           <a:ea typeface="Poppins" pitchFamily="34" charset="-122"/>
                           <a:cs typeface="Poppins" pitchFamily="34" charset="-120"/>
                         </a:rPr>
-                        <a:t>Q 1000.00</a:t>
+                        <a:t>Q 1,000.00</a:t>
                       </a:r>
                       <a:endParaRPr lang="en-US" sz="1300" dirty="0">
                         <a:latin typeface="Poppins" charset="0"/>
@@ -7127,7 +7127,7 @@
                           <a:ea typeface="Calibri" pitchFamily="34" charset="-122"/>
                           <a:cs typeface="Calibri" pitchFamily="34" charset="-120"/>
                         </a:rPr>
-                        <a:t>Pasarela de pago (≈ 4 % de Q 1,015)</a:t>
+                        <a:t>Pasarela (4.5 % si paga con tarjeta, 70 % de los casos)</a:t>
                       </a:r>
                       <a:endParaRPr lang="en-US" sz="1300" dirty="0">
                         <a:latin typeface="Calibri" charset="0"/>
@@ -7192,7 +7192,7 @@
                           <a:ea typeface="Poppins" pitchFamily="34" charset="-122"/>
                           <a:cs typeface="Poppins" pitchFamily="34" charset="-120"/>
                         </a:rPr>
-                        <a:t>– Q 40.60</a:t>
+                        <a:t>– Q 31.97</a:t>
                       </a:r>
                       <a:endParaRPr lang="en-US" sz="1300" dirty="0">
                         <a:latin typeface="Poppins" charset="0"/>
@@ -7459,7 +7459,7 @@
                           <a:ea typeface="Poppins" pitchFamily="34" charset="-122"/>
                           <a:cs typeface="Poppins" pitchFamily="34" charset="-120"/>
                         </a:rPr>
-                        <a:t>Q 54.40</a:t>
+                        <a:t>Q 63.03</a:t>
                       </a:r>
                       <a:endParaRPr lang="en-US" sz="1600" dirty="0">
                         <a:latin typeface="Poppins" charset="0"/>
@@ -7575,7 +7575,7 @@
                 <a:ea typeface="Poppins" pitchFamily="34" charset="-122"/>
                 <a:cs typeface="Poppins" pitchFamily="34" charset="-120"/>
               </a:rPr>
-              <a:t>Q 54</a:t>
+              <a:t>Q 63</a:t>
             </a:r>
             <a:endParaRPr lang="en-US" sz="2400" dirty="0"/>
           </a:p>
@@ -7929,7 +7929,7 @@
                 <a:ea typeface="Calibri" pitchFamily="34" charset="-122"/>
                 <a:cs typeface="Calibri" pitchFamily="34" charset="-120"/>
               </a:rPr>
-              <a:t>trabajos al mes para cubrir Q 4,080 de costos fijos (punto de equilibrio)</a:t>
+              <a:t>trabajos al mes para cubrir Q 4,700 de costos fijos (punto de equilibrio)</a:t>
             </a:r>
             <a:endParaRPr lang="en-US" sz="1200" dirty="0"/>
           </a:p>
@@ -7968,7 +7968,7 @@
                 <a:ea typeface="Calibri" pitchFamily="34" charset="-122"/>
                 <a:cs typeface="Calibri" pitchFamily="34" charset="-120"/>
               </a:rPr>
-              <a:t>Supuestos del piloto (a validar): trabajo promedio de Q 1,000, porque el 47.6 % de la encuesta pagó entre Q 500 y Q 1,500 por su último trabajo; comisión de 10 %, porque el 61.9 % no pagaría más de 10 % extra; costos fijos de Q 4,080 al mes, porque el equipo y la oficina los aporta Artefacto Creativo. Las emergencias suman Q 37.50 por visita.</a:t>
+              <a:t>Supuestos del piloto (a validar): trabajo promedio de Q 1,000, porque el 47.6 % de la encuesta pagó entre Q 500 y Q 1,500 por su último trabajo; comisión de 10 %, porque el 61.9 % no pagaría más de 10 % extra; costos fijos de Q 4,700 al mes (agente a medio tiempo con salario mínimo 2026, plataforma, marketing y contabilidad), porque la oficina la aporta Artefacto Creativo; pasarela de 4.5 % solo con tarjeta, porque la transferencia no tiene costo. Las emergencias suman Q 37.50 por visita.</a:t>
             </a:r>
             <a:endParaRPr lang="en-US" sz="1050" dirty="0"/>
           </a:p>

</xml_diff>